<commit_message>
updated lesson 7,8 + lab 6
</commit_message>
<xml_diff>
--- a/lab_06-navigation/lab_06-navigation.pptx
+++ b/lab_06-navigation/lab_06-navigation.pptx
@@ -240,7 +240,7 @@
           <a:p>
             <a:fld id="{81C4B3FE-0320-8142-8396-5C3025C019EC}" type="datetimeFigureOut">
               <a:rPr lang="en-IT" smtClean="0"/>
-              <a:t>5/4/24</a:t>
+              <a:t>4/7/25</a:t>
             </a:fld>
             <a:endParaRPr lang="en-IT"/>
           </a:p>
@@ -2214,7 +2214,9 @@
           <a:lstStyle>
             <a:lvl1pPr marL="0" indent="0" algn="ctr">
               <a:buNone/>
-              <a:defRPr sz="4800" b="1"/>
+              <a:defRPr sz="4800" b="1">
+                <a:latin typeface="Aptos" panose="020B0004020202020204" pitchFamily="34" charset="0"/>
+              </a:defRPr>
             </a:lvl1pPr>
             <a:lvl2pPr marL="457200" indent="0" algn="ctr">
               <a:buNone/>
@@ -2300,7 +2302,9 @@
           <a:lstStyle/>
           <a:p>
             <a:pPr algn="ctr"/>
-            <a:endParaRPr lang="en-GB" dirty="0"/>
+            <a:endParaRPr lang="en-GB" dirty="0">
+              <a:latin typeface="Aptos" panose="020B0004020202020204" pitchFamily="34" charset="0"/>
+            </a:endParaRPr>
           </a:p>
         </p:txBody>
       </p:sp>
@@ -2350,7 +2354,9 @@
           <a:lstStyle/>
           <a:p>
             <a:pPr algn="ctr"/>
-            <a:endParaRPr lang="en-GB" dirty="0"/>
+            <a:endParaRPr lang="en-GB" dirty="0">
+              <a:latin typeface="Aptos" panose="020B0004020202020204" pitchFamily="34" charset="0"/>
+            </a:endParaRPr>
           </a:p>
         </p:txBody>
       </p:sp>
@@ -2396,36 +2402,52 @@
           </a:lstStyle>
           <a:p>
             <a:r>
-              <a:rPr lang="it-IT" sz="2800" b="0" dirty="0" err="1"/>
+              <a:rPr lang="it-IT" sz="2800" b="0" dirty="0" err="1">
+                <a:latin typeface="Aptos" panose="020B0004020202020204" pitchFamily="34" charset="0"/>
+              </a:rPr>
               <a:t>Biomedical</a:t>
             </a:r>
             <a:r>
-              <a:rPr lang="it-IT" sz="2800" b="0" dirty="0"/>
+              <a:rPr lang="it-IT" sz="2800" b="0" dirty="0">
+                <a:latin typeface="Aptos" panose="020B0004020202020204" pitchFamily="34" charset="0"/>
+              </a:rPr>
               <a:t> </a:t>
             </a:r>
             <a:r>
-              <a:rPr lang="it-IT" sz="2800" b="0" dirty="0" err="1"/>
+              <a:rPr lang="it-IT" sz="2800" b="0" dirty="0" err="1">
+                <a:latin typeface="Aptos" panose="020B0004020202020204" pitchFamily="34" charset="0"/>
+              </a:rPr>
               <a:t>Wearable</a:t>
             </a:r>
             <a:r>
-              <a:rPr lang="it-IT" sz="2800" b="0" dirty="0"/>
+              <a:rPr lang="it-IT" sz="2800" b="0" dirty="0">
+                <a:latin typeface="Aptos" panose="020B0004020202020204" pitchFamily="34" charset="0"/>
+              </a:rPr>
               <a:t> Technologies </a:t>
             </a:r>
           </a:p>
           <a:p>
             <a:r>
-              <a:rPr lang="it-IT" sz="2800" b="0" dirty="0"/>
+              <a:rPr lang="it-IT" sz="2800" b="0" dirty="0">
+                <a:latin typeface="Aptos" panose="020B0004020202020204" pitchFamily="34" charset="0"/>
+              </a:rPr>
               <a:t>for Healthcare and </a:t>
             </a:r>
             <a:r>
-              <a:rPr lang="it-IT" sz="2800" b="0" dirty="0" err="1"/>
+              <a:rPr lang="it-IT" sz="2800" b="0" dirty="0" err="1">
+                <a:latin typeface="Aptos" panose="020B0004020202020204" pitchFamily="34" charset="0"/>
+              </a:rPr>
               <a:t>Wellbeing</a:t>
             </a:r>
             <a:r>
-              <a:rPr lang="it-IT" sz="2800" b="0" dirty="0"/>
+              <a:rPr lang="it-IT" sz="2800" b="0" dirty="0">
+                <a:latin typeface="Aptos" panose="020B0004020202020204" pitchFamily="34" charset="0"/>
+              </a:rPr>
               <a:t>  </a:t>
             </a:r>
-            <a:endParaRPr lang="en-GB" sz="2800" b="0" dirty="0"/>
+            <a:endParaRPr lang="en-GB" sz="2800" b="0" dirty="0">
+              <a:latin typeface="Aptos" panose="020B0004020202020204" pitchFamily="34" charset="0"/>
+            </a:endParaRPr>
           </a:p>
         </p:txBody>
       </p:sp>
@@ -2476,8 +2498,10 @@
               </a:spcAft>
             </a:pPr>
             <a:r>
-              <a:rPr lang="it-IT" sz="2800" dirty="0"/>
-              <a:t>A.Y. 2023-2024</a:t>
+              <a:rPr lang="it-IT" sz="2800" dirty="0">
+                <a:latin typeface="Aptos" panose="020B0004020202020204" pitchFamily="34" charset="0"/>
+              </a:rPr>
+              <a:t>A.Y. 2024-2025</a:t>
             </a:r>
           </a:p>
         </p:txBody>
@@ -2516,7 +2540,7 @@
                 <a:effectLst/>
                 <a:uLnTx/>
                 <a:uFillTx/>
-                <a:latin typeface="Palatino Linotype" panose="02040502050505030304" pitchFamily="18" charset="0"/>
+                <a:latin typeface="Aptos" panose="020B0004020202020204" pitchFamily="34" charset="0"/>
                 <a:ea typeface="+mj-ea"/>
                 <a:cs typeface="+mj-cs"/>
               </a:rPr>
@@ -2533,7 +2557,7 @@
                 <a:effectLst/>
                 <a:uLnTx/>
                 <a:uFillTx/>
-                <a:latin typeface="Palatino Linotype" panose="02040502050505030304" pitchFamily="18" charset="0"/>
+                <a:latin typeface="Aptos" panose="020B0004020202020204" pitchFamily="34" charset="0"/>
                 <a:ea typeface="+mj-ea"/>
                 <a:cs typeface="+mj-cs"/>
               </a:rPr>
@@ -2550,7 +2574,7 @@
                 <a:effectLst/>
                 <a:uLnTx/>
                 <a:uFillTx/>
-                <a:latin typeface="Palatino Linotype" panose="02040502050505030304" pitchFamily="18" charset="0"/>
+                <a:latin typeface="Aptos" panose="020B0004020202020204" pitchFamily="34" charset="0"/>
                 <a:ea typeface="+mj-ea"/>
                 <a:cs typeface="+mj-cs"/>
               </a:rPr>
@@ -2566,7 +2590,7 @@
                 <a:effectLst/>
                 <a:uLnTx/>
                 <a:uFillTx/>
-                <a:latin typeface="Palatino Linotype" panose="02040502050505030304" pitchFamily="18" charset="0"/>
+                <a:latin typeface="Aptos" panose="020B0004020202020204" pitchFamily="34" charset="0"/>
                 <a:ea typeface="+mj-ea"/>
                 <a:cs typeface="+mj-cs"/>
               </a:rPr>
@@ -2583,7 +2607,7 @@
                 <a:effectLst/>
                 <a:uLnTx/>
                 <a:uFillTx/>
-                <a:latin typeface="Palatino Linotype" panose="02040502050505030304" pitchFamily="18" charset="0"/>
+                <a:latin typeface="Aptos" panose="020B0004020202020204" pitchFamily="34" charset="0"/>
                 <a:ea typeface="+mj-ea"/>
                 <a:cs typeface="+mj-cs"/>
               </a:rPr>
@@ -2600,13 +2624,15 @@
                 <a:effectLst/>
                 <a:uLnTx/>
                 <a:uFillTx/>
-                <a:latin typeface="Palatino Linotype" panose="02040502050505030304" pitchFamily="18" charset="0"/>
+                <a:latin typeface="Aptos" panose="020B0004020202020204" pitchFamily="34" charset="0"/>
                 <a:ea typeface="+mj-ea"/>
                 <a:cs typeface="+mj-cs"/>
               </a:rPr>
               <a:t>Engineering</a:t>
             </a:r>
-            <a:endParaRPr lang="en-GB" sz="1100" cap="small" baseline="0" dirty="0"/>
+            <a:endParaRPr lang="en-GB" sz="1100" cap="small" baseline="0" dirty="0">
+              <a:latin typeface="Aptos" panose="020B0004020202020204" pitchFamily="34" charset="0"/>
+            </a:endParaRPr>
           </a:p>
         </p:txBody>
       </p:sp>
@@ -2716,7 +2742,9 @@
           </a:bodyPr>
           <a:lstStyle>
             <a:lvl1pPr>
-              <a:defRPr sz="3200"/>
+              <a:defRPr sz="3200">
+                <a:latin typeface="Aptos" panose="020B0004020202020204" pitchFamily="34" charset="0"/>
+              </a:defRPr>
             </a:lvl1pPr>
           </a:lstStyle>
           <a:p>
@@ -3116,12 +3144,14 @@
                     <a:tint val="75000"/>
                   </a:schemeClr>
                 </a:solidFill>
+                <a:latin typeface="Aptos" panose="020B0004020202020204" pitchFamily="34" charset="0"/>
               </a:defRPr>
             </a:lvl1pPr>
           </a:lstStyle>
           <a:p>
             <a:fld id="{31DE2C5B-556E-47B8-A792-024C2FCA4ACC}" type="slidenum">
               <a:rPr lang="en-GB" smtClean="0"/>
+              <a:pPr/>
               <a:t>‹#›</a:t>
             </a:fld>
             <a:endParaRPr lang="en-GB"/>
@@ -3157,7 +3187,7 @@
           <a:solidFill>
             <a:schemeClr val="tx1"/>
           </a:solidFill>
-          <a:latin typeface="Palatino Linotype" panose="02040502050505030304" pitchFamily="18" charset="0"/>
+          <a:latin typeface="Aptos" panose="020B0004020202020204" pitchFamily="34" charset="0"/>
           <a:ea typeface="+mj-ea"/>
           <a:cs typeface="+mj-cs"/>
         </a:defRPr>
@@ -3180,7 +3210,7 @@
           <a:solidFill>
             <a:schemeClr val="tx1"/>
           </a:solidFill>
-          <a:latin typeface="Palatino Linotype" panose="02040502050505030304" pitchFamily="18" charset="0"/>
+          <a:latin typeface="Aptos" panose="020B0004020202020204" pitchFamily="34" charset="0"/>
           <a:ea typeface="+mn-ea"/>
           <a:cs typeface="+mn-cs"/>
         </a:defRPr>
@@ -3201,7 +3231,7 @@
           <a:solidFill>
             <a:schemeClr val="tx1"/>
           </a:solidFill>
-          <a:latin typeface="Palatino Linotype" panose="02040502050505030304" pitchFamily="18" charset="0"/>
+          <a:latin typeface="Aptos" panose="020B0004020202020204" pitchFamily="34" charset="0"/>
           <a:ea typeface="+mn-ea"/>
           <a:cs typeface="+mn-cs"/>
         </a:defRPr>
@@ -3222,7 +3252,7 @@
           <a:solidFill>
             <a:schemeClr val="tx1"/>
           </a:solidFill>
-          <a:latin typeface="Palatino Linotype" panose="02040502050505030304" pitchFamily="18" charset="0"/>
+          <a:latin typeface="Aptos" panose="020B0004020202020204" pitchFamily="34" charset="0"/>
           <a:ea typeface="+mn-ea"/>
           <a:cs typeface="+mn-cs"/>
         </a:defRPr>
@@ -3243,7 +3273,7 @@
           <a:solidFill>
             <a:schemeClr val="tx1"/>
           </a:solidFill>
-          <a:latin typeface="Palatino Linotype" panose="02040502050505030304" pitchFamily="18" charset="0"/>
+          <a:latin typeface="Aptos" panose="020B0004020202020204" pitchFamily="34" charset="0"/>
           <a:ea typeface="+mn-ea"/>
           <a:cs typeface="+mn-cs"/>
         </a:defRPr>
@@ -3264,7 +3294,7 @@
           <a:solidFill>
             <a:schemeClr val="tx1"/>
           </a:solidFill>
-          <a:latin typeface="Palatino Linotype" panose="02040502050505030304" pitchFamily="18" charset="0"/>
+          <a:latin typeface="Aptos" panose="020B0004020202020204" pitchFamily="34" charset="0"/>
           <a:ea typeface="+mn-ea"/>
           <a:cs typeface="+mn-cs"/>
         </a:defRPr>
@@ -4040,6 +4070,7 @@
             </a:pPr>
             <a:r>
               <a:rPr lang="en-IT" sz="1600" dirty="0">
+                <a:latin typeface="Aptos" panose="020B0004020202020204" pitchFamily="34" charset="0"/>
                 <a:ea typeface="Palatino" pitchFamily="2" charset="77"/>
               </a:rPr>
               <a:t>Full example in lab_06-navigation/02-async_and_await.dart</a:t>
@@ -4082,18 +4113,18 @@
           <a:p>
             <a:r>
               <a:rPr lang="en-GB" b="1" dirty="0">
-                <a:latin typeface="Palatino Linotype" panose="02040502050505030304" pitchFamily="18" charset="0"/>
+                <a:latin typeface="Aptos" panose="020B0004020202020204" pitchFamily="34" charset="0"/>
               </a:rPr>
               <a:t>Note</a:t>
             </a:r>
             <a:r>
               <a:rPr lang="en-GB" dirty="0">
-                <a:latin typeface="Palatino Linotype" panose="02040502050505030304" pitchFamily="18" charset="0"/>
+                <a:latin typeface="Aptos" panose="020B0004020202020204" pitchFamily="34" charset="0"/>
               </a:rPr>
               <a:t>: Now ‘Done’ will be print  AFTER ‘Large latte’.</a:t>
             </a:r>
             <a:endParaRPr lang="en-IT" dirty="0">
-              <a:latin typeface="Palatino Linotype" panose="02040502050505030304" pitchFamily="18" charset="0"/>
+              <a:latin typeface="Aptos" panose="020B0004020202020204" pitchFamily="34" charset="0"/>
             </a:endParaRPr>
           </a:p>
         </p:txBody>
@@ -5770,7 +5801,7 @@
             <a:pPr algn="ctr"/>
             <a:r>
               <a:rPr lang="en-IT" b="1" dirty="0">
-                <a:latin typeface="Palatino Linotype" panose="02040502050505030304" pitchFamily="18" charset="0"/>
+                <a:latin typeface="Aptos" panose="020B0004020202020204" pitchFamily="34" charset="0"/>
               </a:rPr>
               <a:t>Navigation stack</a:t>
             </a:r>
@@ -5820,7 +5851,7 @@
             <a:pPr algn="ctr"/>
             <a:r>
               <a:rPr lang="en-IT" b="1" dirty="0">
-                <a:latin typeface="Palatino Linotype" panose="02040502050505030304" pitchFamily="18" charset="0"/>
+                <a:latin typeface="Aptos" panose="020B0004020202020204" pitchFamily="34" charset="0"/>
               </a:rPr>
               <a:t>Navigation stack</a:t>
             </a:r>
@@ -5870,7 +5901,7 @@
             <a:pPr algn="ctr"/>
             <a:r>
               <a:rPr lang="en-IT" b="1" dirty="0">
-                <a:latin typeface="Palatino Linotype" panose="02040502050505030304" pitchFamily="18" charset="0"/>
+                <a:latin typeface="Aptos" panose="020B0004020202020204" pitchFamily="34" charset="0"/>
               </a:rPr>
               <a:t>Navigation stack</a:t>
             </a:r>
@@ -5892,7 +5923,7 @@
         <p:spPr>
           <a:xfrm>
             <a:off x="2774895" y="5805457"/>
-            <a:ext cx="2028825" cy="369332"/>
+            <a:ext cx="1932004" cy="369332"/>
           </a:xfrm>
           <a:prstGeom prst="rect">
             <a:avLst/>
@@ -5906,7 +5937,7 @@
           <a:p>
             <a:r>
               <a:rPr lang="en-IT" dirty="0">
-                <a:latin typeface="Palatino Linotype" panose="02040502050505030304" pitchFamily="18" charset="0"/>
+                <a:latin typeface="Aptos" panose="020B0004020202020204" pitchFamily="34" charset="0"/>
               </a:rPr>
               <a:t>Go to ProfilePage </a:t>
             </a:r>
@@ -5928,7 +5959,7 @@
         <p:spPr>
           <a:xfrm>
             <a:off x="7169248" y="5805457"/>
-            <a:ext cx="1982338" cy="369332"/>
+            <a:ext cx="1905330" cy="369332"/>
           </a:xfrm>
           <a:prstGeom prst="rect">
             <a:avLst/>
@@ -5942,7 +5973,7 @@
           <a:p>
             <a:r>
               <a:rPr lang="en-IT" dirty="0">
-                <a:latin typeface="Palatino Linotype" panose="02040502050505030304" pitchFamily="18" charset="0"/>
+                <a:latin typeface="Aptos" panose="020B0004020202020204" pitchFamily="34" charset="0"/>
               </a:rPr>
               <a:t>Go to HomePage </a:t>
             </a:r>
@@ -8930,9 +8961,15 @@
           <a:p>
             <a:r>
               <a:rPr lang="en-IT" dirty="0">
+                <a:latin typeface="Aptos" panose="020B0004020202020204" pitchFamily="34" charset="0"/>
+              </a:rPr>
+              <a:t>Current</a:t>
+            </a:r>
+            <a:r>
+              <a:rPr lang="en-IT" dirty="0">
                 <a:latin typeface="Palatino Linotype" panose="02040502050505030304" pitchFamily="18" charset="0"/>
               </a:rPr>
-              <a:t>Current </a:t>
+              <a:t> </a:t>
             </a:r>
             <a:r>
               <a:rPr lang="en-IT" dirty="0">
@@ -8972,7 +9009,7 @@
           <a:p>
             <a:r>
               <a:rPr lang="en-IT" dirty="0">
-                <a:latin typeface="Palatino Linotype" panose="02040502050505030304" pitchFamily="18" charset="0"/>
+                <a:latin typeface="Aptos" panose="020B0004020202020204" pitchFamily="34" charset="0"/>
               </a:rPr>
               <a:t>The new </a:t>
             </a:r>
@@ -8986,7 +9023,13 @@
               <a:rPr lang="en-IT" dirty="0">
                 <a:latin typeface="Palatino Linotype" panose="02040502050505030304" pitchFamily="18" charset="0"/>
               </a:rPr>
-              <a:t> to be pushed into the stack</a:t>
+              <a:t> </a:t>
+            </a:r>
+            <a:r>
+              <a:rPr lang="en-IT" dirty="0">
+                <a:latin typeface="Aptos" panose="020B0004020202020204" pitchFamily="34" charset="0"/>
+              </a:rPr>
+              <a:t>to be pushed into the stack</a:t>
             </a:r>
           </a:p>
         </p:txBody>
@@ -9240,7 +9283,9 @@
           </a:lstStyle>
           <a:p>
             <a:r>
-              <a:rPr lang="en-IT" dirty="0"/>
+              <a:rPr lang="en-IT" dirty="0">
+                <a:latin typeface="Aptos" panose="020B0004020202020204" pitchFamily="34" charset="0"/>
+              </a:rPr>
               <a:t>To pop the ProfilePage route, simply invoke </a:t>
             </a:r>
             <a:r>
@@ -9808,7 +9853,7 @@
             <a:pPr algn="ctr"/>
             <a:r>
               <a:rPr lang="en-IT" b="1" dirty="0">
-                <a:latin typeface="Palatino Linotype" panose="02040502050505030304" pitchFamily="18" charset="0"/>
+                <a:latin typeface="Aptos" panose="020B0004020202020204" pitchFamily="34" charset="0"/>
               </a:rPr>
               <a:t>Navigation stack</a:t>
             </a:r>
@@ -9858,7 +9903,7 @@
             <a:pPr algn="ctr"/>
             <a:r>
               <a:rPr lang="en-IT" b="1" dirty="0">
-                <a:latin typeface="Palatino Linotype" panose="02040502050505030304" pitchFamily="18" charset="0"/>
+                <a:latin typeface="Aptos" panose="020B0004020202020204" pitchFamily="34" charset="0"/>
               </a:rPr>
               <a:t>Navigation stack</a:t>
             </a:r>
@@ -9908,7 +9953,7 @@
             <a:pPr algn="ctr"/>
             <a:r>
               <a:rPr lang="en-IT" b="1" dirty="0">
-                <a:latin typeface="Palatino Linotype" panose="02040502050505030304" pitchFamily="18" charset="0"/>
+                <a:latin typeface="Aptos" panose="020B0004020202020204" pitchFamily="34" charset="0"/>
               </a:rPr>
               <a:t>Navigation stack</a:t>
             </a:r>
@@ -10501,7 +10546,7 @@
             <a:pPr algn="ctr"/>
             <a:r>
               <a:rPr lang="en-IT" b="1" dirty="0">
-                <a:latin typeface="Palatino Linotype" panose="02040502050505030304" pitchFamily="18" charset="0"/>
+                <a:latin typeface="Aptos" panose="020B0004020202020204" pitchFamily="34" charset="0"/>
               </a:rPr>
               <a:t>Navigation stack</a:t>
             </a:r>
@@ -10551,7 +10596,7 @@
             <a:pPr algn="ctr"/>
             <a:r>
               <a:rPr lang="en-IT" b="1" dirty="0">
-                <a:latin typeface="Palatino Linotype" panose="02040502050505030304" pitchFamily="18" charset="0"/>
+                <a:latin typeface="Aptos" panose="020B0004020202020204" pitchFamily="34" charset="0"/>
               </a:rPr>
               <a:t>Navigation stack</a:t>
             </a:r>
@@ -10601,7 +10646,7 @@
             <a:pPr algn="ctr"/>
             <a:r>
               <a:rPr lang="en-IT" b="1" dirty="0">
-                <a:latin typeface="Palatino Linotype" panose="02040502050505030304" pitchFamily="18" charset="0"/>
+                <a:latin typeface="Aptos" panose="020B0004020202020204" pitchFamily="34" charset="0"/>
               </a:rPr>
               <a:t>Navigation stack</a:t>
             </a:r>
@@ -11352,7 +11397,7 @@
             <a:pPr algn="ctr"/>
             <a:r>
               <a:rPr lang="en-IT" dirty="0">
-                <a:latin typeface="Palatino Linotype" panose="02040502050505030304" pitchFamily="18" charset="0"/>
+                <a:latin typeface="Aptos" panose="020B0004020202020204" pitchFamily="34" charset="0"/>
                 <a:ea typeface="Palatino" pitchFamily="2" charset="77"/>
               </a:rPr>
               <a:t>BONUS</a:t>
@@ -11655,7 +11700,7 @@
           <a:p>
             <a:r>
               <a:rPr lang="en-GB" dirty="0">
-                <a:latin typeface="Palatino Linotype" panose="02040502050505030304" pitchFamily="18" charset="0"/>
+                <a:latin typeface="Aptos" panose="020B0004020202020204" pitchFamily="34" charset="0"/>
               </a:rPr>
               <a:t>This maps names to the corresponding routes within the app</a:t>
             </a:r>
@@ -11691,12 +11736,12 @@
           <a:p>
             <a:r>
               <a:rPr lang="en-GB" dirty="0">
-                <a:latin typeface="Palatino Linotype" panose="02040502050505030304" pitchFamily="18" charset="0"/>
+                <a:latin typeface="Aptos" panose="020B0004020202020204" pitchFamily="34" charset="0"/>
               </a:rPr>
               <a:t>This specifies the app entry point</a:t>
             </a:r>
             <a:endParaRPr lang="en-IT" dirty="0">
-              <a:latin typeface="Palatino Linotype" panose="02040502050505030304" pitchFamily="18" charset="0"/>
+              <a:latin typeface="Aptos" panose="020B0004020202020204" pitchFamily="34" charset="0"/>
             </a:endParaRPr>
           </a:p>
         </p:txBody>
@@ -11859,7 +11904,7 @@
             <a:pPr algn="ctr"/>
             <a:r>
               <a:rPr lang="en-IT" dirty="0">
-                <a:latin typeface="Palatino Linotype" panose="02040502050505030304" pitchFamily="18" charset="0"/>
+                <a:latin typeface="Aptos" panose="020B0004020202020204" pitchFamily="34" charset="0"/>
                 <a:ea typeface="Palatino" pitchFamily="2" charset="77"/>
               </a:rPr>
               <a:t>BONUS</a:t>
@@ -12634,24 +12679,38 @@
           </a:lstStyle>
           <a:p>
             <a:r>
-              <a:rPr lang="en-IT" dirty="0"/>
+              <a:rPr lang="en-IT" dirty="0">
+                <a:latin typeface="Aptos" panose="020B0004020202020204" pitchFamily="34" charset="0"/>
+              </a:rPr>
               <a:t>To pop the </a:t>
             </a:r>
             <a:r>
+              <a:rPr lang="en-IT">
+                <a:latin typeface="Courier" pitchFamily="2" charset="0"/>
+              </a:rPr>
+              <a:t>ProfilePage</a:t>
+            </a:r>
+            <a:r>
+              <a:rPr lang="en-IT"/>
+              <a:t> </a:t>
+            </a:r>
+            <a:r>
               <a:rPr lang="en-IT" dirty="0">
-                <a:latin typeface="Courier" pitchFamily="2" charset="0"/>
-              </a:rPr>
-              <a:t>ProfilePage</a:t>
-            </a:r>
-            <a:r>
-              <a:rPr lang="en-IT" dirty="0"/>
-              <a:t> route, you can still use </a:t>
+                <a:latin typeface="Aptos" panose="020B0004020202020204" pitchFamily="34" charset="0"/>
+              </a:rPr>
+              <a:t>route, you can still use </a:t>
+            </a:r>
+            <a:r>
+              <a:rPr lang="en-IT">
+                <a:latin typeface="Courier" pitchFamily="2" charset="0"/>
+              </a:rPr>
+              <a:t>Navigator</a:t>
             </a:r>
             <a:r>
               <a:rPr lang="en-IT" dirty="0">
                 <a:latin typeface="Courier" pitchFamily="2" charset="0"/>
               </a:rPr>
-              <a:t>Navigator.pop()</a:t>
+              <a:t>.pop()</a:t>
             </a:r>
             <a:r>
               <a:rPr lang="en-IT" dirty="0"/>
@@ -13188,7 +13247,7 @@
             <a:pPr algn="ctr"/>
             <a:r>
               <a:rPr lang="en-IT" b="1" dirty="0">
-                <a:latin typeface="Palatino Linotype" panose="02040502050505030304" pitchFamily="18" charset="0"/>
+                <a:latin typeface="Aptos" panose="020B0004020202020204" pitchFamily="34" charset="0"/>
               </a:rPr>
               <a:t>Navigation stack</a:t>
             </a:r>
@@ -13238,7 +13297,7 @@
             <a:pPr algn="ctr"/>
             <a:r>
               <a:rPr lang="en-IT" b="1" dirty="0">
-                <a:latin typeface="Palatino Linotype" panose="02040502050505030304" pitchFamily="18" charset="0"/>
+                <a:latin typeface="Aptos" panose="020B0004020202020204" pitchFamily="34" charset="0"/>
               </a:rPr>
               <a:t>Navigation stack</a:t>
             </a:r>
@@ -13288,7 +13347,7 @@
             <a:pPr algn="ctr"/>
             <a:r>
               <a:rPr lang="en-IT" b="1" dirty="0">
-                <a:latin typeface="Palatino Linotype" panose="02040502050505030304" pitchFamily="18" charset="0"/>
+                <a:latin typeface="Aptos" panose="020B0004020202020204" pitchFamily="34" charset="0"/>
               </a:rPr>
               <a:t>Navigation stack</a:t>
             </a:r>
@@ -13530,7 +13589,7 @@
             <a:pPr algn="ctr"/>
             <a:r>
               <a:rPr lang="en-IT" dirty="0">
-                <a:latin typeface="Palatino Linotype" panose="02040502050505030304" pitchFamily="18" charset="0"/>
+                <a:latin typeface="Aptos" panose="020B0004020202020204" pitchFamily="34" charset="0"/>
                 <a:ea typeface="Palatino" pitchFamily="2" charset="77"/>
               </a:rPr>
               <a:t>BONUS</a:t>
@@ -15353,7 +15412,9 @@
           </a:lstStyle>
           <a:p>
             <a:r>
-              <a:rPr lang="en-IT" sz="2200" dirty="0"/>
+              <a:rPr lang="en-IT" sz="2200" dirty="0">
+                <a:latin typeface="Aptos" panose="020B0004020202020204" pitchFamily="34" charset="0"/>
+              </a:rPr>
               <a:t>Note: to make this work we need to modify the constructor of </a:t>
             </a:r>
             <a:r>
@@ -16192,7 +16253,9 @@
           </a:lstStyle>
           <a:p>
             <a:r>
-              <a:rPr lang="en-IT" sz="2200" dirty="0"/>
+              <a:rPr lang="en-IT" sz="2200" dirty="0">
+                <a:latin typeface="Aptos" panose="020B0004020202020204" pitchFamily="34" charset="0"/>
+              </a:rPr>
               <a:t>Then, we can finally show the message:</a:t>
             </a:r>
           </a:p>
@@ -18221,33 +18284,69 @@
           <a:p>
             <a:r>
               <a:rPr lang="en-IT" dirty="0">
+                <a:latin typeface="Aptos" panose="020B0004020202020204" pitchFamily="34" charset="0"/>
+              </a:rPr>
+              <a:t>The</a:t>
+            </a:r>
+            <a:r>
+              <a:rPr lang="en-IT">
                 <a:latin typeface="Palatino Linotype" panose="02040502050505030304" pitchFamily="18" charset="0"/>
               </a:rPr>
-              <a:t>The value that will return to the </a:t>
+              <a:t> </a:t>
             </a:r>
             <a:r>
               <a:rPr lang="en-IT" dirty="0">
+                <a:latin typeface="Aptos" panose="020B0004020202020204" pitchFamily="34" charset="0"/>
+              </a:rPr>
+              <a:t>value that will return to the </a:t>
+            </a:r>
+            <a:r>
+              <a:rPr lang="en-IT">
                 <a:latin typeface="Courier" pitchFamily="2" charset="0"/>
               </a:rPr>
               <a:t>HomePage</a:t>
+            </a:r>
+            <a:r>
+              <a:rPr lang="en-IT">
+                <a:latin typeface="Palatino Linotype" panose="02040502050505030304" pitchFamily="18" charset="0"/>
+              </a:rPr>
+              <a:t> </a:t>
+            </a:r>
+            <a:r>
+              <a:rPr lang="en-IT" dirty="0">
+                <a:latin typeface="Aptos" panose="020B0004020202020204" pitchFamily="34" charset="0"/>
+              </a:rPr>
+              <a:t>once</a:t>
+            </a:r>
+            <a:r>
+              <a:rPr lang="en-IT">
+                <a:latin typeface="Palatino Linotype" panose="02040502050505030304" pitchFamily="18" charset="0"/>
+              </a:rPr>
+              <a:t> </a:t>
+            </a:r>
+            <a:r>
+              <a:rPr lang="en-IT" dirty="0">
+                <a:latin typeface="Courier" pitchFamily="2" charset="0"/>
+              </a:rPr>
+              <a:t>PickValuePage</a:t>
             </a:r>
             <a:r>
               <a:rPr lang="en-IT" dirty="0">
                 <a:latin typeface="Palatino Linotype" panose="02040502050505030304" pitchFamily="18" charset="0"/>
               </a:rPr>
-              <a:t> once </a:t>
+              <a:t> </a:t>
+            </a:r>
+            <a:r>
+              <a:rPr lang="en-IT">
+                <a:latin typeface="Palatino Linotype" panose="02040502050505030304" pitchFamily="18" charset="0"/>
+              </a:rPr>
+              <a:t>is </a:t>
             </a:r>
             <a:r>
               <a:rPr lang="en-IT" dirty="0">
-                <a:latin typeface="Courier" pitchFamily="2" charset="0"/>
-              </a:rPr>
-              <a:t>PickValuePage</a:t>
-            </a:r>
-            <a:r>
-              <a:rPr lang="en-IT" dirty="0">
-                <a:latin typeface="Palatino Linotype" panose="02040502050505030304" pitchFamily="18" charset="0"/>
-              </a:rPr>
-              <a:t> is popped out from the stack</a:t>
+                <a:latin typeface="Aptos" panose="020B0004020202020204" pitchFamily="34" charset="0"/>
+              </a:rPr>
+              <a:t>popped out from the stack</a:t>
             </a:r>
           </a:p>
         </p:txBody>
@@ -18742,17 +18841,19 @@
           </a:lstStyle>
           <a:p>
             <a:r>
-              <a:rPr lang="en-IT" sz="2200" dirty="0"/>
+              <a:rPr lang="en-IT" sz="2000" dirty="0">
+                <a:latin typeface="Aptos" panose="020B0004020202020204" pitchFamily="34" charset="0"/>
+              </a:rPr>
               <a:t>Note that you can return ANYTHING, not just a </a:t>
             </a:r>
             <a:r>
-              <a:rPr lang="en-IT" sz="2200" dirty="0">
+              <a:rPr lang="en-IT">
                 <a:latin typeface="Courier" pitchFamily="2" charset="0"/>
               </a:rPr>
               <a:t>String</a:t>
             </a:r>
             <a:r>
-              <a:rPr lang="en-IT" sz="2200" dirty="0"/>
+              <a:rPr lang="en-IT" dirty="0"/>
               <a:t>. </a:t>
             </a:r>
           </a:p>
@@ -18968,21 +19069,27 @@
           <a:p>
             <a:r>
               <a:rPr lang="en-IT" dirty="0">
+                <a:latin typeface="Aptos" panose="020B0004020202020204" pitchFamily="34" charset="0"/>
+              </a:rPr>
+              <a:t>Await means async stuff. The </a:t>
+            </a:r>
+            <a:r>
+              <a:rPr lang="en-IT">
+                <a:latin typeface="Courier" pitchFamily="2" charset="0"/>
+              </a:rPr>
+              <a:t>onPressed</a:t>
+            </a:r>
+            <a:r>
+              <a:rPr lang="en-IT">
                 <a:latin typeface="Palatino Linotype" panose="02040502050505030304" pitchFamily="18" charset="0"/>
               </a:rPr>
-              <a:t>Await means async stuff. The </a:t>
+              <a:t> </a:t>
             </a:r>
             <a:r>
               <a:rPr lang="en-IT" dirty="0">
-                <a:latin typeface="Courier" pitchFamily="2" charset="0"/>
-              </a:rPr>
-              <a:t>onPressed</a:t>
-            </a:r>
-            <a:r>
-              <a:rPr lang="en-IT" dirty="0">
-                <a:latin typeface="Palatino Linotype" panose="02040502050505030304" pitchFamily="18" charset="0"/>
-              </a:rPr>
-              <a:t> function become asynchronous as well so…</a:t>
+                <a:latin typeface="Aptos" panose="020B0004020202020204" pitchFamily="34" charset="0"/>
+              </a:rPr>
+              <a:t>function become asynchronous as well so…</a:t>
             </a:r>
           </a:p>
         </p:txBody>
@@ -19657,6 +19764,7 @@
             </a:pPr>
             <a:r>
               <a:rPr lang="en-IT" sz="1600" dirty="0">
+                <a:latin typeface="Aptos" panose="020B0004020202020204" pitchFamily="34" charset="0"/>
                 <a:ea typeface="Palatino" pitchFamily="2" charset="77"/>
               </a:rPr>
               <a:t>Full example in lab_06-navigation/there_and_back_again/</a:t>
@@ -19966,7 +20074,7 @@
             <a:pPr algn="ctr"/>
             <a:r>
               <a:rPr lang="en-IT" dirty="0">
-                <a:latin typeface="Palatino Linotype" panose="02040502050505030304" pitchFamily="18" charset="0"/>
+                <a:latin typeface="Aptos" panose="020B0004020202020204" pitchFamily="34" charset="0"/>
                 <a:ea typeface="Palatino" pitchFamily="2" charset="77"/>
               </a:rPr>
               <a:t>BONUS</a:t>
@@ -24159,6 +24267,7 @@
             </a:pPr>
             <a:r>
               <a:rPr lang="en-IT" sz="1600" dirty="0">
+                <a:latin typeface="Aptos" panose="020B0004020202020204" pitchFamily="34" charset="0"/>
                 <a:ea typeface="Palatino" pitchFamily="2" charset="77"/>
               </a:rPr>
               <a:t>Full example in lab_06-navigation/01-introducing_futures.dart</a:t>
@@ -24195,12 +24304,12 @@
           <a:p>
             <a:r>
               <a:rPr lang="en-GB" dirty="0">
-                <a:latin typeface="Palatino Linotype" panose="02040502050505030304" pitchFamily="18" charset="0"/>
+                <a:latin typeface="Aptos" panose="020B0004020202020204" pitchFamily="34" charset="0"/>
               </a:rPr>
               <a:t>The function is doing some asynchronous stuff.</a:t>
             </a:r>
             <a:endParaRPr lang="en-IT" dirty="0">
-              <a:latin typeface="Courier" pitchFamily="2" charset="0"/>
+              <a:latin typeface="Aptos" panose="020B0004020202020204" pitchFamily="34" charset="0"/>
             </a:endParaRPr>
           </a:p>
         </p:txBody>
@@ -24240,18 +24349,18 @@
           <a:p>
             <a:r>
               <a:rPr lang="en-GB" b="1" dirty="0">
-                <a:latin typeface="Palatino Linotype" panose="02040502050505030304" pitchFamily="18" charset="0"/>
+                <a:latin typeface="Aptos" panose="020B0004020202020204" pitchFamily="34" charset="0"/>
               </a:rPr>
               <a:t>Note</a:t>
             </a:r>
             <a:r>
               <a:rPr lang="en-GB" dirty="0">
-                <a:latin typeface="Palatino Linotype" panose="02040502050505030304" pitchFamily="18" charset="0"/>
+                <a:latin typeface="Aptos" panose="020B0004020202020204" pitchFamily="34" charset="0"/>
               </a:rPr>
               <a:t>: ‘Done’ will be print before ‘Large latte’. How to fix this?</a:t>
             </a:r>
             <a:endParaRPr lang="en-IT" dirty="0">
-              <a:latin typeface="Palatino Linotype" panose="02040502050505030304" pitchFamily="18" charset="0"/>
+              <a:latin typeface="Aptos" panose="020B0004020202020204" pitchFamily="34" charset="0"/>
             </a:endParaRPr>
           </a:p>
         </p:txBody>
@@ -24291,18 +24400,18 @@
           <a:p>
             <a:r>
               <a:rPr lang="en-GB" b="1" dirty="0">
-                <a:latin typeface="Palatino Linotype" panose="02040502050505030304" pitchFamily="18" charset="0"/>
+                <a:latin typeface="Aptos" panose="020B0004020202020204" pitchFamily="34" charset="0"/>
               </a:rPr>
               <a:t>Note</a:t>
             </a:r>
             <a:r>
               <a:rPr lang="en-GB" dirty="0">
-                <a:latin typeface="Palatino Linotype" panose="02040502050505030304" pitchFamily="18" charset="0"/>
+                <a:latin typeface="Aptos" panose="020B0004020202020204" pitchFamily="34" charset="0"/>
               </a:rPr>
               <a:t>: main is an asynchronous function now</a:t>
             </a:r>
             <a:endParaRPr lang="en-IT" dirty="0">
-              <a:latin typeface="Palatino Linotype" panose="02040502050505030304" pitchFamily="18" charset="0"/>
+              <a:latin typeface="Aptos" panose="020B0004020202020204" pitchFamily="34" charset="0"/>
             </a:endParaRPr>
           </a:p>
         </p:txBody>

</xml_diff>